<commit_message>
Last update (grade 10 given)
</commit_message>
<xml_diff>
--- a/Poster_Disertatie_Retinopatie_Diabetica.pptx
+++ b/Poster_Disertatie_Retinopatie_Diabetica.pptx
@@ -137,115 +137,6 @@
 </p188:authorLst>
 </file>
 
-<file path=ppt/comments/modernComment_104_75507553.xml><?xml version="1.0" encoding="utf-8"?>
-<p188:cmLst xmlns:a="http://schemas.openxmlformats.org/drawingml/2006/main" xmlns:r="http://schemas.openxmlformats.org/officeDocument/2006/relationships" xmlns:p188="http://schemas.microsoft.com/office/powerpoint/2018/8/main">
-  <p188:cm id="{0AAC2A28-BDC4-4E83-82FD-63411B7F4541}" authorId="{A2822312-285A-EE07-5195-C85D3D4420B6}" created="2025-05-13T10:41:52.118">
-    <ac:deMkLst xmlns:ac="http://schemas.microsoft.com/office/drawing/2013/main/command">
-      <pc:docMk xmlns:pc="http://schemas.microsoft.com/office/powerpoint/2013/main/command"/>
-      <pc:sldMk xmlns:pc="http://schemas.microsoft.com/office/powerpoint/2013/main/command" cId="1968207187" sldId="260"/>
-      <ac:spMk id="14" creationId="{7BD96CFE-E0BD-6CA0-2F01-594F06B4A320}"/>
-    </ac:deMkLst>
-    <p188:txBody>
-      <a:bodyPr/>
-      <a:lstStyle/>
-      <a:p>
-        <a:r>
-          <a:rPr lang="en-US"/>
-          <a:t>Titlul lucrării - Font Arial Bold, dimensiunea 22</a:t>
-        </a:r>
-      </a:p>
-    </p188:txBody>
-  </p188:cm>
-  <p188:cm id="{068AA0DB-3086-4969-8053-09C9BD2C3556}" authorId="{A2822312-285A-EE07-5195-C85D3D4420B6}" created="2025-05-13T10:43:45.362">
-    <ac:deMkLst xmlns:ac="http://schemas.microsoft.com/office/drawing/2013/main/command">
-      <pc:docMk xmlns:pc="http://schemas.microsoft.com/office/powerpoint/2013/main/command"/>
-      <pc:sldMk xmlns:pc="http://schemas.microsoft.com/office/powerpoint/2013/main/command" cId="1968207187" sldId="260"/>
-      <ac:spMk id="17" creationId="{C9D81920-32AD-1FC7-D9A7-592BC7436A17}"/>
-    </ac:deMkLst>
-    <p188:txBody>
-      <a:bodyPr/>
-      <a:lstStyle/>
-      <a:p>
-        <a:r>
-          <a:rPr lang="en-US"/>
-          <a:t>Arial dimensiunea 12
-Student/Studentă (bold)
-Profesor sau Profesori Coordonatori (Bold)</a:t>
-        </a:r>
-      </a:p>
-    </p188:txBody>
-  </p188:cm>
-  <p188:cm id="{B883DB88-EB8F-47FA-8B98-9433CB33026F}" authorId="{A2822312-285A-EE07-5195-C85D3D4420B6}" created="2025-05-13T10:44:26.689">
-    <ac:deMkLst xmlns:ac="http://schemas.microsoft.com/office/drawing/2013/main/command">
-      <pc:docMk xmlns:pc="http://schemas.microsoft.com/office/powerpoint/2013/main/command"/>
-      <pc:sldMk xmlns:pc="http://schemas.microsoft.com/office/powerpoint/2013/main/command" cId="1968207187" sldId="260"/>
-      <ac:spMk id="45" creationId="{4CE2D894-CA62-EF1F-E487-570C911A900B}"/>
-    </ac:deMkLst>
-    <p188:txBody>
-      <a:bodyPr/>
-      <a:lstStyle/>
-      <a:p>
-        <a:r>
-          <a:rPr lang="en-US"/>
-          <a:t>Toate secțiunile lucrării Arial dimeniunea 10</a:t>
-        </a:r>
-      </a:p>
-    </p188:txBody>
-  </p188:cm>
-  <p188:cm id="{BA4D9125-0697-4426-9FF7-06D09F2446DA}" authorId="{A2822312-285A-EE07-5195-C85D3D4420B6}" created="2025-05-13T10:44:52.508">
-    <ac:deMkLst xmlns:ac="http://schemas.microsoft.com/office/drawing/2013/main/command">
-      <pc:docMk xmlns:pc="http://schemas.microsoft.com/office/powerpoint/2013/main/command"/>
-      <pc:sldMk xmlns:pc="http://schemas.microsoft.com/office/powerpoint/2013/main/command" cId="1968207187" sldId="260"/>
-      <ac:spMk id="38" creationId="{9F715CB6-EED3-9A42-033C-79467F5C611B}"/>
-    </ac:deMkLst>
-    <p188:txBody>
-      <a:bodyPr/>
-      <a:lstStyle/>
-      <a:p>
-        <a:r>
-          <a:rPr lang="en-US"/>
-          <a:t>Spațiu dedicat poze/grafice etc.</a:t>
-        </a:r>
-      </a:p>
-    </p188:txBody>
-  </p188:cm>
-  <p188:cm id="{E91D824A-6952-4314-8956-C541E0624A12}" authorId="{A2822312-285A-EE07-5195-C85D3D4420B6}" created="2025-05-13T10:45:20.689">
-    <ac:deMkLst xmlns:ac="http://schemas.microsoft.com/office/drawing/2013/main/command">
-      <pc:docMk xmlns:pc="http://schemas.microsoft.com/office/powerpoint/2013/main/command"/>
-      <pc:sldMk xmlns:pc="http://schemas.microsoft.com/office/powerpoint/2013/main/command" cId="1968207187" sldId="260"/>
-      <ac:grpSpMk id="21" creationId="{45988B13-8A94-F40A-65E7-662E61CA7E24}"/>
-    </ac:deMkLst>
-    <p188:txBody>
-      <a:bodyPr/>
-      <a:lstStyle/>
-      <a:p>
-        <a:r>
-          <a:rPr lang="en-US"/>
-          <a:t>Spațiu dedicat poze/grafice etc.</a:t>
-        </a:r>
-      </a:p>
-    </p188:txBody>
-  </p188:cm>
-  <p188:cm id="{0D3AD74E-EC3E-440D-A851-C748B72D25A7}" authorId="{A2822312-285A-EE07-5195-C85D3D4420B6}" created="2025-05-13T10:45:36.116">
-    <ac:deMkLst xmlns:ac="http://schemas.microsoft.com/office/drawing/2013/main/command">
-      <pc:docMk xmlns:pc="http://schemas.microsoft.com/office/powerpoint/2013/main/command"/>
-      <pc:sldMk xmlns:pc="http://schemas.microsoft.com/office/powerpoint/2013/main/command" cId="1968207187" sldId="260"/>
-      <ac:spMk id="28" creationId="{14FF541B-F844-5895-DCC2-142E3202D446}"/>
-    </ac:deMkLst>
-    <p188:txBody>
-      <a:bodyPr/>
-      <a:lstStyle/>
-      <a:p>
-        <a:r>
-          <a:rPr lang="en-US"/>
-          <a:t>Spațiu dedicat poze/grafice etc.</a:t>
-        </a:r>
-      </a:p>
-    </p188:txBody>
-  </p188:cm>
-</p188:cmLst>
-</file>
-
 <file path=ppt/slideLayouts/slideLayout1.xml><?xml version="1.0" encoding="utf-8"?>
 <p:sldLayout xmlns:a="http://schemas.openxmlformats.org/drawingml/2006/main" xmlns:r="http://schemas.openxmlformats.org/officeDocument/2006/relationships" xmlns:p="http://schemas.openxmlformats.org/presentationml/2006/main" type="title" preserve="1">
   <p:cSld name="Title Slide">
@@ -426,7 +317,7 @@
             <a:fld id="{1D8BD707-D9CF-40AE-B4C6-C98DA3205C09}" type="datetimeFigureOut">
               <a:rPr lang="en-US" smtClean="0"/>
               <a:pPr/>
-              <a:t>6/15/2026</a:t>
+              <a:t>6/19/2026</a:t>
             </a:fld>
             <a:endParaRPr lang="en-US"/>
           </a:p>
@@ -591,7 +482,7 @@
             <a:fld id="{1D8BD707-D9CF-40AE-B4C6-C98DA3205C09}" type="datetimeFigureOut">
               <a:rPr lang="en-US" smtClean="0"/>
               <a:pPr/>
-              <a:t>6/15/2026</a:t>
+              <a:t>6/19/2026</a:t>
             </a:fld>
             <a:endParaRPr lang="en-US"/>
           </a:p>
@@ -766,7 +657,7 @@
             <a:fld id="{1D8BD707-D9CF-40AE-B4C6-C98DA3205C09}" type="datetimeFigureOut">
               <a:rPr lang="en-US" smtClean="0"/>
               <a:pPr/>
-              <a:t>6/15/2026</a:t>
+              <a:t>6/19/2026</a:t>
             </a:fld>
             <a:endParaRPr lang="en-US"/>
           </a:p>
@@ -931,7 +822,7 @@
             <a:fld id="{1D8BD707-D9CF-40AE-B4C6-C98DA3205C09}" type="datetimeFigureOut">
               <a:rPr lang="en-US" smtClean="0"/>
               <a:pPr/>
-              <a:t>6/15/2026</a:t>
+              <a:t>6/19/2026</a:t>
             </a:fld>
             <a:endParaRPr lang="en-US"/>
           </a:p>
@@ -1173,7 +1064,7 @@
             <a:fld id="{1D8BD707-D9CF-40AE-B4C6-C98DA3205C09}" type="datetimeFigureOut">
               <a:rPr lang="en-US" smtClean="0"/>
               <a:pPr/>
-              <a:t>6/15/2026</a:t>
+              <a:t>6/19/2026</a:t>
             </a:fld>
             <a:endParaRPr lang="en-US"/>
           </a:p>
@@ -1455,7 +1346,7 @@
             <a:fld id="{1D8BD707-D9CF-40AE-B4C6-C98DA3205C09}" type="datetimeFigureOut">
               <a:rPr lang="en-US" smtClean="0"/>
               <a:pPr/>
-              <a:t>6/15/2026</a:t>
+              <a:t>6/19/2026</a:t>
             </a:fld>
             <a:endParaRPr lang="en-US"/>
           </a:p>
@@ -1871,7 +1762,7 @@
             <a:fld id="{1D8BD707-D9CF-40AE-B4C6-C98DA3205C09}" type="datetimeFigureOut">
               <a:rPr lang="en-US" smtClean="0"/>
               <a:pPr/>
-              <a:t>6/15/2026</a:t>
+              <a:t>6/19/2026</a:t>
             </a:fld>
             <a:endParaRPr lang="en-US"/>
           </a:p>
@@ -1985,7 +1876,7 @@
             <a:fld id="{1D8BD707-D9CF-40AE-B4C6-C98DA3205C09}" type="datetimeFigureOut">
               <a:rPr lang="en-US" smtClean="0"/>
               <a:pPr/>
-              <a:t>6/15/2026</a:t>
+              <a:t>6/19/2026</a:t>
             </a:fld>
             <a:endParaRPr lang="en-US"/>
           </a:p>
@@ -2077,7 +1968,7 @@
             <a:fld id="{1D8BD707-D9CF-40AE-B4C6-C98DA3205C09}" type="datetimeFigureOut">
               <a:rPr lang="en-US" smtClean="0"/>
               <a:pPr/>
-              <a:t>6/15/2026</a:t>
+              <a:t>6/19/2026</a:t>
             </a:fld>
             <a:endParaRPr lang="en-US"/>
           </a:p>
@@ -2349,7 +2240,7 @@
             <a:fld id="{1D8BD707-D9CF-40AE-B4C6-C98DA3205C09}" type="datetimeFigureOut">
               <a:rPr lang="en-US" smtClean="0"/>
               <a:pPr/>
-              <a:t>6/15/2026</a:t>
+              <a:t>6/19/2026</a:t>
             </a:fld>
             <a:endParaRPr lang="en-US"/>
           </a:p>
@@ -2598,7 +2489,7 @@
             <a:fld id="{1D8BD707-D9CF-40AE-B4C6-C98DA3205C09}" type="datetimeFigureOut">
               <a:rPr lang="en-US" smtClean="0"/>
               <a:pPr/>
-              <a:t>6/15/2026</a:t>
+              <a:t>6/19/2026</a:t>
             </a:fld>
             <a:endParaRPr lang="en-US"/>
           </a:p>
@@ -2806,7 +2697,7 @@
             <a:fld id="{1D8BD707-D9CF-40AE-B4C6-C98DA3205C09}" type="datetimeFigureOut">
               <a:rPr lang="en-US" smtClean="0"/>
               <a:pPr/>
-              <a:t>6/15/2026</a:t>
+              <a:t>6/19/2026</a:t>
             </a:fld>
             <a:endParaRPr lang="en-US"/>
           </a:p>
@@ -3291,7 +3182,7 @@
             <a:blip>
               <a:extLst>
                 <a:ext uri="{96DAC541-7B7A-43D3-8B79-37D633B846F1}">
-                  <asvg:svgBlip xmlns:asvg="http://schemas.microsoft.com/office/drawing/2016/SVG/main" r:embed="rId3"/>
+                  <asvg:svgBlip xmlns:asvg="http://schemas.microsoft.com/office/drawing/2016/SVG/main" r:embed="rId2"/>
                 </a:ext>
               </a:extLst>
             </a:blip>
@@ -3358,7 +3249,7 @@
             <a:blip>
               <a:extLst>
                 <a:ext uri="{96DAC541-7B7A-43D3-8B79-37D633B846F1}">
-                  <asvg:svgBlip xmlns:asvg="http://schemas.microsoft.com/office/drawing/2016/SVG/main" r:embed="rId3"/>
+                  <asvg:svgBlip xmlns:asvg="http://schemas.microsoft.com/office/drawing/2016/SVG/main" r:embed="rId2"/>
                 </a:ext>
               </a:extLst>
             </a:blip>
@@ -3559,7 +3450,7 @@
             </a:pathLst>
           </a:custGeom>
           <a:blipFill>
-            <a:blip r:embed="rId4"/>
+            <a:blip r:embed="rId3"/>
             <a:stretch>
               <a:fillRect/>
             </a:stretch>
@@ -8118,7 +8009,7 @@
                 <a:cs typeface="Arial" panose="020B0604020202020204" pitchFamily="34" charset="0"/>
                 <a:sym typeface="Arial"/>
               </a:rPr>
-              <a:t>: Accuracy, Macro F1, Balanced Accuracy, AUC </a:t>
+              <a:t>: Accuracy, Macro F1, AUC </a:t>
             </a:r>
             <a:r>
               <a:rPr lang="en-US" sz="1400" dirty="0" err="1">
@@ -9313,10 +9204,40 @@
       </p:sp>
       <p:pic>
         <p:nvPicPr>
-          <p:cNvPr id="9" name="Picture 8">
+          <p:cNvPr id="19" name="Picture 18">
             <a:extLst>
               <a:ext uri="{FF2B5EF4-FFF2-40B4-BE49-F238E27FC236}">
-                <a16:creationId xmlns:a16="http://schemas.microsoft.com/office/drawing/2014/main" id="{ADA9EB38-68B4-CB6F-C2CF-C4A661E7CFBD}"/>
+                <a16:creationId xmlns:a16="http://schemas.microsoft.com/office/drawing/2014/main" id="{C6B11734-1F8D-4849-4599-50B6572139AC}"/>
+              </a:ext>
+            </a:extLst>
+          </p:cNvPr>
+          <p:cNvPicPr>
+            <a:picLocks noChangeAspect="1"/>
+          </p:cNvPicPr>
+          <p:nvPr/>
+        </p:nvPicPr>
+        <p:blipFill>
+          <a:blip r:embed="rId4"/>
+          <a:stretch>
+            <a:fillRect/>
+          </a:stretch>
+        </p:blipFill>
+        <p:spPr>
+          <a:xfrm>
+            <a:off x="11872288" y="3192877"/>
+            <a:ext cx="2713558" cy="3682982"/>
+          </a:xfrm>
+          <a:prstGeom prst="rect">
+            <a:avLst/>
+          </a:prstGeom>
+        </p:spPr>
+      </p:pic>
+      <p:pic>
+        <p:nvPicPr>
+          <p:cNvPr id="24" name="Picture 23">
+            <a:extLst>
+              <a:ext uri="{FF2B5EF4-FFF2-40B4-BE49-F238E27FC236}">
+                <a16:creationId xmlns:a16="http://schemas.microsoft.com/office/drawing/2014/main" id="{02FB3220-1933-E1F1-33D8-7AD42CA83A05}"/>
               </a:ext>
             </a:extLst>
           </p:cNvPr>
@@ -9333,8 +9254,8 @@
         </p:blipFill>
         <p:spPr>
           <a:xfrm>
-            <a:off x="11856948" y="3410761"/>
-            <a:ext cx="2779424" cy="3372311"/>
+            <a:off x="593222" y="3193795"/>
+            <a:ext cx="3373958" cy="2692840"/>
           </a:xfrm>
           <a:prstGeom prst="rect">
             <a:avLst/>
@@ -9343,10 +9264,10 @@
       </p:pic>
       <p:pic>
         <p:nvPicPr>
-          <p:cNvPr id="21" name="Picture 20">
+          <p:cNvPr id="28" name="Picture 27">
             <a:extLst>
               <a:ext uri="{FF2B5EF4-FFF2-40B4-BE49-F238E27FC236}">
-                <a16:creationId xmlns:a16="http://schemas.microsoft.com/office/drawing/2014/main" id="{F3555829-FFDF-DE50-6942-D555BA962A4C}"/>
+                <a16:creationId xmlns:a16="http://schemas.microsoft.com/office/drawing/2014/main" id="{66EE2F81-4FA7-A8D8-7DF9-8CE355EBF9CA}"/>
               </a:ext>
             </a:extLst>
           </p:cNvPr>
@@ -9363,8 +9284,8 @@
         </p:blipFill>
         <p:spPr>
           <a:xfrm>
-            <a:off x="652848" y="3036712"/>
-            <a:ext cx="3262586" cy="2822137"/>
+            <a:off x="3988984" y="5726141"/>
+            <a:ext cx="1961396" cy="1216562"/>
           </a:xfrm>
           <a:prstGeom prst="rect">
             <a:avLst/>
@@ -9373,10 +9294,10 @@
       </p:pic>
       <p:pic>
         <p:nvPicPr>
-          <p:cNvPr id="23" name="Picture 22">
+          <p:cNvPr id="34" name="Picture 33">
             <a:extLst>
               <a:ext uri="{FF2B5EF4-FFF2-40B4-BE49-F238E27FC236}">
-                <a16:creationId xmlns:a16="http://schemas.microsoft.com/office/drawing/2014/main" id="{3A3D67B0-90DE-EC93-6584-562A204D60DF}"/>
+                <a16:creationId xmlns:a16="http://schemas.microsoft.com/office/drawing/2014/main" id="{D992C15F-7BD7-B437-B2E8-108205A3DFAB}"/>
               </a:ext>
             </a:extLst>
           </p:cNvPr>
@@ -9393,8 +9314,8 @@
         </p:blipFill>
         <p:spPr>
           <a:xfrm>
-            <a:off x="4096377" y="5769629"/>
-            <a:ext cx="1951450" cy="1210393"/>
+            <a:off x="5984181" y="5619732"/>
+            <a:ext cx="2411989" cy="1275352"/>
           </a:xfrm>
           <a:prstGeom prst="rect">
             <a:avLst/>
@@ -9403,10 +9324,10 @@
       </p:pic>
       <p:pic>
         <p:nvPicPr>
-          <p:cNvPr id="25" name="Picture 24">
+          <p:cNvPr id="36" name="Picture 35">
             <a:extLst>
               <a:ext uri="{FF2B5EF4-FFF2-40B4-BE49-F238E27FC236}">
-                <a16:creationId xmlns:a16="http://schemas.microsoft.com/office/drawing/2014/main" id="{4F3988FF-E92A-EAAE-CA66-C1A7D44720BE}"/>
+                <a16:creationId xmlns:a16="http://schemas.microsoft.com/office/drawing/2014/main" id="{C1277AA4-CC1A-2143-E43E-8BA9FB1909AB}"/>
               </a:ext>
             </a:extLst>
           </p:cNvPr>
@@ -9423,8 +9344,8 @@
         </p:blipFill>
         <p:spPr>
           <a:xfrm>
-            <a:off x="6193992" y="5807306"/>
-            <a:ext cx="1895627" cy="1002323"/>
+            <a:off x="4071895" y="7020473"/>
+            <a:ext cx="1820210" cy="1128991"/>
           </a:xfrm>
           <a:prstGeom prst="rect">
             <a:avLst/>
@@ -9433,10 +9354,10 @@
       </p:pic>
       <p:pic>
         <p:nvPicPr>
-          <p:cNvPr id="27" name="Picture 26">
+          <p:cNvPr id="38" name="Picture 37">
             <a:extLst>
               <a:ext uri="{FF2B5EF4-FFF2-40B4-BE49-F238E27FC236}">
-                <a16:creationId xmlns:a16="http://schemas.microsoft.com/office/drawing/2014/main" id="{99710974-5C12-6A99-2FC3-54163826A512}"/>
+                <a16:creationId xmlns:a16="http://schemas.microsoft.com/office/drawing/2014/main" id="{BC4F842F-6215-A94E-646A-3CCDFEF216F7}"/>
               </a:ext>
             </a:extLst>
           </p:cNvPr>
@@ -9453,38 +9374,8 @@
         </p:blipFill>
         <p:spPr>
           <a:xfrm>
-            <a:off x="4085531" y="6980022"/>
-            <a:ext cx="1781175" cy="1104779"/>
-          </a:xfrm>
-          <a:prstGeom prst="rect">
-            <a:avLst/>
-          </a:prstGeom>
-        </p:spPr>
-      </p:pic>
-      <p:pic>
-        <p:nvPicPr>
-          <p:cNvPr id="30" name="Picture 29">
-            <a:extLst>
-              <a:ext uri="{FF2B5EF4-FFF2-40B4-BE49-F238E27FC236}">
-                <a16:creationId xmlns:a16="http://schemas.microsoft.com/office/drawing/2014/main" id="{BB91914F-9C3E-26B5-9084-480E6A1CF013}"/>
-              </a:ext>
-            </a:extLst>
-          </p:cNvPr>
-          <p:cNvPicPr>
-            <a:picLocks noChangeAspect="1"/>
-          </p:cNvPicPr>
-          <p:nvPr/>
-        </p:nvPicPr>
-        <p:blipFill>
-          <a:blip r:embed="rId10"/>
-          <a:stretch>
-            <a:fillRect/>
-          </a:stretch>
-        </p:blipFill>
-        <p:spPr>
-          <a:xfrm flipV="1">
-            <a:off x="5939246" y="6986771"/>
-            <a:ext cx="2955577" cy="1187629"/>
+            <a:off x="6054423" y="6976482"/>
+            <a:ext cx="2831456" cy="1137755"/>
           </a:xfrm>
           <a:prstGeom prst="rect">
             <a:avLst/>
@@ -9501,11 +9392,6 @@
   <p:clrMapOvr>
     <a:masterClrMapping/>
   </p:clrMapOvr>
-  <p:extLst>
-    <p:ext uri="{6950BFC3-D8DA-4A85-94F7-54DA5524770B}">
-      <p188:commentRel xmlns:p188="http://schemas.microsoft.com/office/powerpoint/2018/8/main" r:id="rId2"/>
-    </p:ext>
-  </p:extLst>
 </p:sld>
 </file>
 

</xml_diff>